<commit_message>
Sync PPTX presentation with latest web changes
</commit_message>
<xml_diff>
--- a/경영전략본부_2026년3분기_발표용_웹기반.pptx
+++ b/경영전략본부_2026년3분기_발표용_웹기반.pptx
@@ -5205,6 +5205,10 @@
             <a:prstDash val="solid"/>
           </a:ln>
         </p:spPr>
+        <p:txBody>
+          <a:bodyPr/>
+          <a:p/>
+        </p:txBody>
       </p:sp>
       <p:sp>
         <p:nvSpPr>
@@ -5239,6 +5243,10 @@
             </a:outerShdw>
           </a:effectLst>
         </p:spPr>
+        <p:txBody>
+          <a:bodyPr/>
+          <a:p/>
+        </p:txBody>
       </p:sp>
       <p:pic>
         <p:nvPicPr>
@@ -5405,6 +5413,10 @@
             <a:prstDash val="solid"/>
           </a:ln>
         </p:spPr>
+        <p:txBody>
+          <a:bodyPr/>
+          <a:p/>
+        </p:txBody>
       </p:sp>
       <p:sp>
         <p:nvSpPr>
@@ -5439,6 +5451,10 @@
             </a:outerShdw>
           </a:effectLst>
         </p:spPr>
+        <p:txBody>
+          <a:bodyPr/>
+          <a:p/>
+        </p:txBody>
       </p:sp>
       <p:pic>
         <p:nvPicPr>
@@ -5604,6 +5620,10 @@
             <a:prstDash val="solid"/>
           </a:ln>
         </p:spPr>
+        <p:txBody>
+          <a:bodyPr/>
+          <a:p/>
+        </p:txBody>
       </p:sp>
       <p:sp>
         <p:nvSpPr>
@@ -5746,6 +5766,10 @@
             <a:prstDash val="solid"/>
           </a:ln>
         </p:spPr>
+        <p:txBody>
+          <a:bodyPr/>
+          <a:p/>
+        </p:txBody>
       </p:sp>
       <p:sp>
         <p:nvSpPr>
@@ -5780,6 +5804,10 @@
             </a:outerShdw>
           </a:effectLst>
         </p:spPr>
+        <p:txBody>
+          <a:bodyPr/>
+          <a:p/>
+        </p:txBody>
       </p:sp>
       <p:pic>
         <p:nvPicPr>
@@ -5945,6 +5973,10 @@
             <a:prstDash val="solid"/>
           </a:ln>
         </p:spPr>
+        <p:txBody>
+          <a:bodyPr/>
+          <a:p/>
+        </p:txBody>
       </p:sp>
       <p:sp>
         <p:nvSpPr>
@@ -6087,6 +6119,10 @@
             <a:prstDash val="solid"/>
           </a:ln>
         </p:spPr>
+        <p:txBody>
+          <a:bodyPr/>
+          <a:p/>
+        </p:txBody>
       </p:sp>
       <p:sp>
         <p:nvSpPr>
@@ -6121,6 +6157,10 @@
             </a:outerShdw>
           </a:effectLst>
         </p:spPr>
+        <p:txBody>
+          <a:bodyPr/>
+          <a:p/>
+        </p:txBody>
       </p:sp>
       <p:pic>
         <p:nvPicPr>
@@ -6286,6 +6326,10 @@
             <a:prstDash val="solid"/>
           </a:ln>
         </p:spPr>
+        <p:txBody>
+          <a:bodyPr/>
+          <a:p/>
+        </p:txBody>
       </p:sp>
       <p:sp>
         <p:nvSpPr>
@@ -6396,6 +6440,10 @@
             </a:outerShdw>
           </a:effectLst>
         </p:spPr>
+        <p:txBody>
+          <a:bodyPr/>
+          <a:p/>
+        </p:txBody>
       </p:sp>
       <p:sp>
         <p:nvSpPr>
@@ -6571,6 +6619,10 @@
             </a:outerShdw>
           </a:effectLst>
         </p:spPr>
+        <p:txBody>
+          <a:bodyPr/>
+          <a:p/>
+        </p:txBody>
       </p:sp>
       <p:pic>
         <p:nvPicPr>
@@ -6745,6 +6797,10 @@
             </a:outerShdw>
           </a:effectLst>
         </p:spPr>
+        <p:txBody>
+          <a:bodyPr/>
+          <a:p/>
+        </p:txBody>
       </p:sp>
       <p:pic>
         <p:nvPicPr>
@@ -6919,6 +6975,10 @@
             </a:outerShdw>
           </a:effectLst>
         </p:spPr>
+        <p:txBody>
+          <a:bodyPr/>
+          <a:p/>
+        </p:txBody>
       </p:sp>
       <p:pic>
         <p:nvPicPr>
@@ -7093,6 +7153,10 @@
             </a:outerShdw>
           </a:effectLst>
         </p:spPr>
+        <p:txBody>
+          <a:bodyPr/>
+          <a:p/>
+        </p:txBody>
       </p:sp>
       <p:pic>
         <p:nvPicPr>
@@ -7267,6 +7331,10 @@
             </a:outerShdw>
           </a:effectLst>
         </p:spPr>
+        <p:txBody>
+          <a:bodyPr/>
+          <a:p/>
+        </p:txBody>
       </p:sp>
       <p:pic>
         <p:nvPicPr>
@@ -7441,6 +7509,10 @@
             </a:outerShdw>
           </a:effectLst>
         </p:spPr>
+        <p:txBody>
+          <a:bodyPr/>
+          <a:p/>
+        </p:txBody>
       </p:sp>
       <p:pic>
         <p:nvPicPr>
@@ -7615,6 +7687,10 @@
             </a:outerShdw>
           </a:effectLst>
         </p:spPr>
+        <p:txBody>
+          <a:bodyPr/>
+          <a:p/>
+        </p:txBody>
       </p:sp>
       <p:pic>
         <p:nvPicPr>
@@ -7789,6 +7865,10 @@
             </a:outerShdw>
           </a:effectLst>
         </p:spPr>
+        <p:txBody>
+          <a:bodyPr/>
+          <a:p/>
+        </p:txBody>
       </p:sp>
       <p:pic>
         <p:nvPicPr>
@@ -7963,6 +8043,10 @@
             </a:outerShdw>
           </a:effectLst>
         </p:spPr>
+        <p:txBody>
+          <a:bodyPr/>
+          <a:p/>
+        </p:txBody>
       </p:sp>
       <p:pic>
         <p:nvPicPr>
@@ -8137,6 +8221,10 @@
             </a:outerShdw>
           </a:effectLst>
         </p:spPr>
+        <p:txBody>
+          <a:bodyPr/>
+          <a:p/>
+        </p:txBody>
       </p:sp>
       <p:pic>
         <p:nvPicPr>
@@ -8311,6 +8399,10 @@
             </a:outerShdw>
           </a:effectLst>
         </p:spPr>
+        <p:txBody>
+          <a:bodyPr/>
+          <a:p/>
+        </p:txBody>
       </p:sp>
       <p:pic>
         <p:nvPicPr>
@@ -8485,6 +8577,10 @@
             </a:outerShdw>
           </a:effectLst>
         </p:spPr>
+        <p:txBody>
+          <a:bodyPr/>
+          <a:p/>
+        </p:txBody>
       </p:sp>
       <p:sp>
         <p:nvSpPr>
@@ -8883,6 +8979,10 @@
             </a:outerShdw>
           </a:effectLst>
         </p:spPr>
+        <p:txBody>
+          <a:bodyPr/>
+          <a:p/>
+        </p:txBody>
       </p:sp>
       <p:sp>
         <p:nvSpPr>
@@ -9058,6 +9158,10 @@
             </a:outerShdw>
           </a:effectLst>
         </p:spPr>
+        <p:txBody>
+          <a:bodyPr/>
+          <a:p/>
+        </p:txBody>
       </p:sp>
       <p:sp>
         <p:nvSpPr>
@@ -9248,6 +9352,10 @@
             </a:outerShdw>
           </a:effectLst>
         </p:spPr>
+        <p:txBody>
+          <a:bodyPr/>
+          <a:p/>
+        </p:txBody>
       </p:sp>
       <p:sp>
         <p:nvSpPr>
@@ -9438,6 +9546,10 @@
             </a:outerShdw>
           </a:effectLst>
         </p:spPr>
+        <p:txBody>
+          <a:bodyPr/>
+          <a:p/>
+        </p:txBody>
       </p:sp>
       <p:sp>
         <p:nvSpPr>
@@ -9628,6 +9740,10 @@
             </a:outerShdw>
           </a:effectLst>
         </p:spPr>
+        <p:txBody>
+          <a:bodyPr/>
+          <a:p/>
+        </p:txBody>
       </p:sp>
       <p:sp>
         <p:nvSpPr>
@@ -9818,6 +9934,10 @@
             </a:outerShdw>
           </a:effectLst>
         </p:spPr>
+        <p:txBody>
+          <a:bodyPr/>
+          <a:p/>
+        </p:txBody>
       </p:sp>
       <p:sp>
         <p:nvSpPr>
@@ -10008,6 +10128,10 @@
             </a:outerShdw>
           </a:effectLst>
         </p:spPr>
+        <p:txBody>
+          <a:bodyPr/>
+          <a:p/>
+        </p:txBody>
       </p:sp>
       <p:sp>
         <p:nvSpPr>
@@ -10073,15 +10197,7 @@
               <a:buNone/>
             </a:pPr>
             <a:r>
-              <a:rPr lang="en-US" sz="1500" b="1" dirty="0">
-                <a:solidFill>
-                  <a:srgbClr val="F5F2EA"/>
-                </a:solidFill>
-                <a:latin typeface="Malgun Gothic" pitchFamily="34" charset="0"/>
-                <a:ea typeface="Malgun Gothic" pitchFamily="34" charset="-122"/>
-                <a:cs typeface="Malgun Gothic" pitchFamily="34" charset="-120"/>
-              </a:rPr>
-              <a:t>좋은타이어 회계 변경</a:t>
+              <a:t>좋은타이어 회계프로그램 변경</a:t>
             </a:r>
             <a:endParaRPr lang="en-US" sz="1500" dirty="0"/>
           </a:p>
@@ -10198,6 +10314,10 @@
             </a:outerShdw>
           </a:effectLst>
         </p:spPr>
+        <p:txBody>
+          <a:bodyPr/>
+          <a:p/>
+        </p:txBody>
       </p:sp>
       <p:sp>
         <p:nvSpPr>
@@ -10388,6 +10508,10 @@
             </a:outerShdw>
           </a:effectLst>
         </p:spPr>
+        <p:txBody>
+          <a:bodyPr/>
+          <a:p/>
+        </p:txBody>
       </p:sp>
       <p:sp>
         <p:nvSpPr>
@@ -10578,6 +10702,10 @@
             </a:outerShdw>
           </a:effectLst>
         </p:spPr>
+        <p:txBody>
+          <a:bodyPr/>
+          <a:p/>
+        </p:txBody>
       </p:sp>
       <p:sp>
         <p:nvSpPr>
@@ -10768,6 +10896,10 @@
             </a:outerShdw>
           </a:effectLst>
         </p:spPr>
+        <p:txBody>
+          <a:bodyPr/>
+          <a:p/>
+        </p:txBody>
       </p:sp>
       <p:sp>
         <p:nvSpPr>
@@ -11034,6 +11166,10 @@
             </a:outerShdw>
           </a:effectLst>
         </p:spPr>
+        <p:txBody>
+          <a:bodyPr/>
+          <a:p/>
+        </p:txBody>
       </p:sp>
       <p:sp>
         <p:nvSpPr>
@@ -11209,6 +11345,10 @@
             </a:outerShdw>
           </a:effectLst>
         </p:spPr>
+        <p:txBody>
+          <a:bodyPr/>
+          <a:p/>
+        </p:txBody>
       </p:sp>
       <p:sp>
         <p:nvSpPr>
@@ -11433,6 +11573,10 @@
             <a:prstDash val="solid"/>
           </a:ln>
         </p:spPr>
+        <p:txBody>
+          <a:bodyPr/>
+          <a:p/>
+        </p:txBody>
       </p:sp>
       <p:sp>
         <p:nvSpPr>
@@ -11497,6 +11641,10 @@
             <a:prstDash val="solid"/>
           </a:ln>
         </p:spPr>
+        <p:txBody>
+          <a:bodyPr/>
+          <a:p/>
+        </p:txBody>
       </p:sp>
       <p:sp>
         <p:nvSpPr>
@@ -11639,6 +11787,10 @@
             <a:prstDash val="solid"/>
           </a:ln>
         </p:spPr>
+        <p:txBody>
+          <a:bodyPr/>
+          <a:p/>
+        </p:txBody>
       </p:sp>
       <p:sp>
         <p:nvSpPr>
@@ -11781,6 +11933,10 @@
             <a:prstDash val="solid"/>
           </a:ln>
         </p:spPr>
+        <p:txBody>
+          <a:bodyPr/>
+          <a:p/>
+        </p:txBody>
       </p:sp>
       <p:sp>
         <p:nvSpPr>
@@ -11923,6 +12079,10 @@
             <a:prstDash val="solid"/>
           </a:ln>
         </p:spPr>
+        <p:txBody>
+          <a:bodyPr/>
+          <a:p/>
+        </p:txBody>
       </p:sp>
       <p:sp>
         <p:nvSpPr>
@@ -11950,6 +12110,10 @@
             <a:prstDash val="solid"/>
           </a:ln>
         </p:spPr>
+        <p:txBody>
+          <a:bodyPr/>
+          <a:p/>
+        </p:txBody>
       </p:sp>
       <p:sp>
         <p:nvSpPr>
@@ -12030,6 +12194,10 @@
             <a:prstDash val="solid"/>
           </a:ln>
         </p:spPr>
+        <p:txBody>
+          <a:bodyPr/>
+          <a:p/>
+        </p:txBody>
       </p:sp>
       <p:sp>
         <p:nvSpPr>
@@ -12110,6 +12278,10 @@
             <a:prstDash val="solid"/>
           </a:ln>
         </p:spPr>
+        <p:txBody>
+          <a:bodyPr/>
+          <a:p/>
+        </p:txBody>
       </p:sp>
       <p:sp>
         <p:nvSpPr>
@@ -12190,6 +12362,10 @@
             <a:prstDash val="solid"/>
           </a:ln>
         </p:spPr>
+        <p:txBody>
+          <a:bodyPr/>
+          <a:p/>
+        </p:txBody>
       </p:sp>
       <p:sp>
         <p:nvSpPr>
@@ -12270,6 +12446,10 @@
             <a:prstDash val="solid"/>
           </a:ln>
         </p:spPr>
+        <p:txBody>
+          <a:bodyPr/>
+          <a:p/>
+        </p:txBody>
       </p:sp>
       <p:sp>
         <p:nvSpPr>
@@ -12350,6 +12530,10 @@
             <a:prstDash val="solid"/>
           </a:ln>
         </p:spPr>
+        <p:txBody>
+          <a:bodyPr/>
+          <a:p/>
+        </p:txBody>
       </p:sp>
       <p:sp>
         <p:nvSpPr>
@@ -12430,6 +12614,10 @@
             <a:prstDash val="solid"/>
           </a:ln>
         </p:spPr>
+        <p:txBody>
+          <a:bodyPr/>
+          <a:p/>
+        </p:txBody>
       </p:sp>
       <p:sp>
         <p:nvSpPr>
@@ -12510,6 +12698,10 @@
             <a:prstDash val="solid"/>
           </a:ln>
         </p:spPr>
+        <p:txBody>
+          <a:bodyPr/>
+          <a:p/>
+        </p:txBody>
       </p:sp>
       <p:sp>
         <p:nvSpPr>
@@ -12590,6 +12782,10 @@
             <a:prstDash val="solid"/>
           </a:ln>
         </p:spPr>
+        <p:txBody>
+          <a:bodyPr/>
+          <a:p/>
+        </p:txBody>
       </p:sp>
       <p:sp>
         <p:nvSpPr>
@@ -12670,6 +12866,10 @@
             <a:prstDash val="solid"/>
           </a:ln>
         </p:spPr>
+        <p:txBody>
+          <a:bodyPr/>
+          <a:p/>
+        </p:txBody>
       </p:sp>
       <p:sp>
         <p:nvSpPr>
@@ -12750,6 +12950,10 @@
             <a:prstDash val="solid"/>
           </a:ln>
         </p:spPr>
+        <p:txBody>
+          <a:bodyPr/>
+          <a:p/>
+        </p:txBody>
       </p:sp>
       <p:sp>
         <p:nvSpPr>
@@ -12830,6 +13034,10 @@
             <a:prstDash val="solid"/>
           </a:ln>
         </p:spPr>
+        <p:txBody>
+          <a:bodyPr/>
+          <a:p/>
+        </p:txBody>
       </p:sp>
       <p:sp>
         <p:nvSpPr>
@@ -12910,6 +13118,10 @@
             <a:prstDash val="solid"/>
           </a:ln>
         </p:spPr>
+        <p:txBody>
+          <a:bodyPr/>
+          <a:p/>
+        </p:txBody>
       </p:sp>
       <p:sp>
         <p:nvSpPr>
@@ -12990,6 +13202,10 @@
             <a:prstDash val="solid"/>
           </a:ln>
         </p:spPr>
+        <p:txBody>
+          <a:bodyPr/>
+          <a:p/>
+        </p:txBody>
       </p:sp>
       <p:sp>
         <p:nvSpPr>
@@ -13070,6 +13286,10 @@
             <a:prstDash val="solid"/>
           </a:ln>
         </p:spPr>
+        <p:txBody>
+          <a:bodyPr/>
+          <a:p/>
+        </p:txBody>
       </p:sp>
       <p:sp>
         <p:nvSpPr>
@@ -13150,6 +13370,10 @@
             <a:prstDash val="solid"/>
           </a:ln>
         </p:spPr>
+        <p:txBody>
+          <a:bodyPr/>
+          <a:p/>
+        </p:txBody>
       </p:sp>
       <p:sp>
         <p:nvSpPr>
@@ -13230,6 +13454,10 @@
             <a:prstDash val="solid"/>
           </a:ln>
         </p:spPr>
+        <p:txBody>
+          <a:bodyPr/>
+          <a:p/>
+        </p:txBody>
       </p:sp>
       <p:sp>
         <p:nvSpPr>
@@ -13310,6 +13538,10 @@
             <a:prstDash val="solid"/>
           </a:ln>
         </p:spPr>
+        <p:txBody>
+          <a:bodyPr/>
+          <a:p/>
+        </p:txBody>
       </p:sp>
       <p:sp>
         <p:nvSpPr>
@@ -13390,6 +13622,10 @@
             <a:prstDash val="solid"/>
           </a:ln>
         </p:spPr>
+        <p:txBody>
+          <a:bodyPr/>
+          <a:p/>
+        </p:txBody>
       </p:sp>
       <p:sp>
         <p:nvSpPr>
@@ -13470,6 +13706,10 @@
             <a:prstDash val="solid"/>
           </a:ln>
         </p:spPr>
+        <p:txBody>
+          <a:bodyPr/>
+          <a:p/>
+        </p:txBody>
       </p:sp>
       <p:sp>
         <p:nvSpPr>
@@ -13550,6 +13790,10 @@
             <a:prstDash val="solid"/>
           </a:ln>
         </p:spPr>
+        <p:txBody>
+          <a:bodyPr/>
+          <a:p/>
+        </p:txBody>
       </p:sp>
       <p:sp>
         <p:nvSpPr>
@@ -13630,6 +13874,10 @@
             <a:prstDash val="solid"/>
           </a:ln>
         </p:spPr>
+        <p:txBody>
+          <a:bodyPr/>
+          <a:p/>
+        </p:txBody>
       </p:sp>
       <p:sp>
         <p:nvSpPr>
@@ -13793,6 +14041,10 @@
             </a:outerShdw>
           </a:effectLst>
         </p:spPr>
+        <p:txBody>
+          <a:bodyPr/>
+          <a:p/>
+        </p:txBody>
       </p:sp>
       <p:sp>
         <p:nvSpPr>
@@ -13968,6 +14220,10 @@
             </a:outerShdw>
           </a:effectLst>
         </p:spPr>
+        <p:txBody>
+          <a:bodyPr/>
+          <a:p/>
+        </p:txBody>
       </p:sp>
       <p:sp>
         <p:nvSpPr>
@@ -14230,6 +14486,10 @@
             </a:outerShdw>
           </a:effectLst>
         </p:spPr>
+        <p:txBody>
+          <a:bodyPr/>
+          <a:p/>
+        </p:txBody>
       </p:sp>
       <p:sp>
         <p:nvSpPr>
@@ -14256,15 +14516,7 @@
               <a:buNone/>
             </a:pPr>
             <a:r>
-              <a:rPr lang="en-US" sz="1400" b="1" dirty="0">
-                <a:solidFill>
-                  <a:srgbClr val="D9B66F"/>
-                </a:solidFill>
-                <a:latin typeface="Malgun Gothic" pitchFamily="34" charset="0"/>
-                <a:ea typeface="Malgun Gothic" pitchFamily="34" charset="-122"/>
-                <a:cs typeface="Malgun Gothic" pitchFamily="34" charset="-120"/>
-              </a:rPr>
-              <a:t>세금업무 · 주민세 사업소분</a:t>
+              <a:t>세금업무 · 사업소분 주민세 · 법인세분 지방소득세</a:t>
             </a:r>
             <a:endParaRPr lang="en-US" sz="1400" dirty="0"/>
           </a:p>
@@ -14373,15 +14625,7 @@
               <a:buNone/>
             </a:pPr>
             <a:r>
-              <a:rPr lang="en-US" sz="1400" dirty="0">
-                <a:solidFill>
-                  <a:srgbClr val="A9B3C9"/>
-                </a:solidFill>
-                <a:latin typeface="Malgun Gothic" pitchFamily="34" charset="0"/>
-                <a:ea typeface="Malgun Gothic" pitchFamily="34" charset="-122"/>
-                <a:cs typeface="Malgun Gothic" pitchFamily="34" charset="-120"/>
-              </a:rPr>
-              <a:t>타이어뱅크 사업소분 직접 신고·납부 완료</a:t>
+              <a:t>타이어뱅크 사업소분 주민세 · 법인세분 지방소득세 직접 신고·납부 완료</a:t>
             </a:r>
             <a:endParaRPr lang="en-US" sz="1400" dirty="0"/>
           </a:p>
@@ -14415,6 +14659,10 @@
             <a:prstDash val="solid"/>
           </a:ln>
         </p:spPr>
+        <p:txBody>
+          <a:bodyPr/>
+          <a:p/>
+        </p:txBody>
       </p:sp>
       <p:sp>
         <p:nvSpPr>
@@ -14527,6 +14775,10 @@
             </a:outerShdw>
           </a:effectLst>
         </p:spPr>
+        <p:txBody>
+          <a:bodyPr/>
+          <a:p/>
+        </p:txBody>
       </p:sp>
       <p:sp>
         <p:nvSpPr>
@@ -14552,6 +14804,10 @@
             <a:prstDash val="solid"/>
           </a:ln>
         </p:spPr>
+        <p:txBody>
+          <a:bodyPr/>
+          <a:p/>
+        </p:txBody>
       </p:sp>
       <p:sp>
         <p:nvSpPr>
@@ -14652,38 +14908,9 @@
           <a:bodyPr wrap="square" lIns="0" tIns="0" rIns="0" bIns="0" rtlCol="0" anchor="t"/>
           <a:lstStyle/>
           <a:p>
-            <a:pPr indent="0" marL="0">
-              <a:buNone/>
-            </a:pPr>
-            <a:r>
-              <a:rPr lang="en-US" sz="1400" dirty="0">
-                <a:solidFill>
-                  <a:srgbClr val="A9B3C9"/>
-                </a:solidFill>
-                <a:latin typeface="Malgun Gothic" pitchFamily="34" charset="0"/>
-                <a:ea typeface="Malgun Gothic" pitchFamily="34" charset="-122"/>
-                <a:cs typeface="Malgun Gothic" pitchFamily="34" charset="-120"/>
-              </a:rPr>
-              <a:t>매월 15일 보고로</a:t>
-            </a:r>
-            <a:endParaRPr lang="en-US" sz="1400" dirty="0"/>
-          </a:p>
-          <a:p>
-            <a:pPr indent="0" marL="0">
-              <a:buNone/>
-            </a:pPr>
-            <a:r>
-              <a:rPr lang="en-US" sz="1400" dirty="0">
-                <a:solidFill>
-                  <a:srgbClr val="A9B3C9"/>
-                </a:solidFill>
-                <a:latin typeface="Malgun Gothic" pitchFamily="34" charset="0"/>
-                <a:ea typeface="Malgun Gothic" pitchFamily="34" charset="-122"/>
-                <a:cs typeface="Malgun Gothic" pitchFamily="34" charset="-120"/>
-              </a:rPr>
-              <a:t>경영자 의사결정 기여</a:t>
-            </a:r>
-            <a:endParaRPr lang="en-US" sz="1400" dirty="0"/>
+            <a:r>
+              <a:t>매월 15일 보고로 합리적인 의사결정에 기여</a:t>
+            </a:r>
           </a:p>
         </p:txBody>
       </p:sp>
@@ -14759,6 +14986,10 @@
             </a:outerShdw>
           </a:effectLst>
         </p:spPr>
+        <p:txBody>
+          <a:bodyPr/>
+          <a:p/>
+        </p:txBody>
       </p:sp>
       <p:sp>
         <p:nvSpPr>
@@ -14784,6 +15015,10 @@
             <a:prstDash val="solid"/>
           </a:ln>
         </p:spPr>
+        <p:txBody>
+          <a:bodyPr/>
+          <a:p/>
+        </p:txBody>
       </p:sp>
       <p:sp>
         <p:nvSpPr>
@@ -14884,38 +15119,9 @@
           <a:bodyPr wrap="square" lIns="0" tIns="0" rIns="0" bIns="0" rtlCol="0" anchor="t"/>
           <a:lstStyle/>
           <a:p>
-            <a:pPr indent="0" marL="0">
-              <a:buNone/>
-            </a:pPr>
-            <a:r>
-              <a:rPr lang="en-US" sz="1400" dirty="0">
-                <a:solidFill>
-                  <a:srgbClr val="A9B3C9"/>
-                </a:solidFill>
-                <a:latin typeface="Malgun Gothic" pitchFamily="34" charset="0"/>
-                <a:ea typeface="Malgun Gothic" pitchFamily="34" charset="-122"/>
-                <a:cs typeface="Malgun Gothic" pitchFamily="34" charset="-120"/>
-              </a:rPr>
-              <a:t>회수 기일 검토로</a:t>
-            </a:r>
-            <a:endParaRPr lang="en-US" sz="1400" dirty="0"/>
-          </a:p>
-          <a:p>
-            <a:pPr indent="0" marL="0">
-              <a:buNone/>
-            </a:pPr>
-            <a:r>
-              <a:rPr lang="en-US" sz="1400" dirty="0">
-                <a:solidFill>
-                  <a:srgbClr val="A9B3C9"/>
-                </a:solidFill>
-                <a:latin typeface="Malgun Gothic" pitchFamily="34" charset="0"/>
-                <a:ea typeface="Malgun Gothic" pitchFamily="34" charset="-122"/>
-                <a:cs typeface="Malgun Gothic" pitchFamily="34" charset="-120"/>
-              </a:rPr>
-              <a:t>대손채권 방지</a:t>
-            </a:r>
-            <a:endParaRPr lang="en-US" sz="1400" dirty="0"/>
+            <a:r>
+              <a:t>회수기일 검토로 대손채권 방지</a:t>
+            </a:r>
           </a:p>
         </p:txBody>
       </p:sp>
@@ -14991,6 +15197,10 @@
             </a:outerShdw>
           </a:effectLst>
         </p:spPr>
+        <p:txBody>
+          <a:bodyPr/>
+          <a:p/>
+        </p:txBody>
       </p:sp>
       <p:sp>
         <p:nvSpPr>
@@ -15016,6 +15226,10 @@
             <a:prstDash val="solid"/>
           </a:ln>
         </p:spPr>
+        <p:txBody>
+          <a:bodyPr/>
+          <a:p/>
+        </p:txBody>
       </p:sp>
       <p:sp>
         <p:nvSpPr>
@@ -15116,38 +15330,9 @@
           <a:bodyPr wrap="square" lIns="0" tIns="0" rIns="0" bIns="0" rtlCol="0" anchor="t"/>
           <a:lstStyle/>
           <a:p>
-            <a:pPr indent="0" marL="0">
-              <a:buNone/>
-            </a:pPr>
-            <a:r>
-              <a:rPr lang="en-US" sz="1400" dirty="0">
-                <a:solidFill>
-                  <a:srgbClr val="A9B3C9"/>
-                </a:solidFill>
-                <a:latin typeface="Malgun Gothic" pitchFamily="34" charset="0"/>
-                <a:ea typeface="Malgun Gothic" pitchFamily="34" charset="-122"/>
-                <a:cs typeface="Malgun Gothic" pitchFamily="34" charset="-120"/>
-              </a:rPr>
-              <a:t>분석을 통한</a:t>
-            </a:r>
-            <a:endParaRPr lang="en-US" sz="1400" dirty="0"/>
-          </a:p>
-          <a:p>
-            <a:pPr indent="0" marL="0">
-              <a:buNone/>
-            </a:pPr>
-            <a:r>
-              <a:rPr lang="en-US" sz="1400" dirty="0">
-                <a:solidFill>
-                  <a:srgbClr val="A9B3C9"/>
-                </a:solidFill>
-                <a:latin typeface="Malgun Gothic" pitchFamily="34" charset="0"/>
-                <a:ea typeface="Malgun Gothic" pitchFamily="34" charset="-122"/>
-                <a:cs typeface="Malgun Gothic" pitchFamily="34" charset="-120"/>
-              </a:rPr>
-              <a:t>원가 통제</a:t>
-            </a:r>
-            <a:endParaRPr lang="en-US" sz="1400" dirty="0"/>
+            <a:r>
+              <a:t>분석을 통한 원가 통제</a:t>
+            </a:r>
           </a:p>
         </p:txBody>
       </p:sp>
@@ -15260,6 +15445,10 @@
             </a:outerShdw>
           </a:effectLst>
         </p:spPr>
+        <p:txBody>
+          <a:bodyPr/>
+          <a:p/>
+        </p:txBody>
       </p:sp>
       <p:sp>
         <p:nvSpPr>
@@ -15426,6 +15615,10 @@
             <a:prstDash val="solid"/>
           </a:ln>
         </p:spPr>
+        <p:txBody>
+          <a:bodyPr/>
+          <a:p/>
+        </p:txBody>
       </p:sp>
       <p:sp>
         <p:nvSpPr>
@@ -15458,6 +15651,10 @@
             </a:outerShdw>
           </a:effectLst>
         </p:spPr>
+        <p:txBody>
+          <a:bodyPr/>
+          <a:p/>
+        </p:txBody>
       </p:sp>
       <p:sp>
         <p:nvSpPr>
@@ -15663,6 +15860,10 @@
             </a:outerShdw>
           </a:effectLst>
         </p:spPr>
+        <p:txBody>
+          <a:bodyPr/>
+          <a:p/>
+        </p:txBody>
       </p:sp>
       <p:sp>
         <p:nvSpPr>
@@ -15868,6 +16069,10 @@
             </a:outerShdw>
           </a:effectLst>
         </p:spPr>
+        <p:txBody>
+          <a:bodyPr/>
+          <a:p/>
+        </p:txBody>
       </p:sp>
       <p:sp>
         <p:nvSpPr>
@@ -16073,6 +16278,10 @@
             </a:outerShdw>
           </a:effectLst>
         </p:spPr>
+        <p:txBody>
+          <a:bodyPr/>
+          <a:p/>
+        </p:txBody>
       </p:sp>
       <p:sp>
         <p:nvSpPr>
@@ -16263,6 +16472,10 @@
             </a:outerShdw>
           </a:effectLst>
         </p:spPr>
+        <p:txBody>
+          <a:bodyPr/>
+          <a:p/>
+        </p:txBody>
       </p:sp>
       <p:sp>
         <p:nvSpPr>
@@ -16292,6 +16505,10 @@
             <a:prstDash val="solid"/>
           </a:ln>
         </p:spPr>
+        <p:txBody>
+          <a:bodyPr/>
+          <a:p/>
+        </p:txBody>
       </p:sp>
       <p:sp>
         <p:nvSpPr>
@@ -16471,6 +16688,10 @@
             </a:outerShdw>
           </a:effectLst>
         </p:spPr>
+        <p:txBody>
+          <a:bodyPr/>
+          <a:p/>
+        </p:txBody>
       </p:sp>
       <p:sp>
         <p:nvSpPr>
@@ -16684,6 +16905,10 @@
             </a:outerShdw>
           </a:effectLst>
         </p:spPr>
+        <p:txBody>
+          <a:bodyPr/>
+          <a:p/>
+        </p:txBody>
       </p:sp>
       <p:sp>
         <p:nvSpPr>
@@ -16859,6 +17084,10 @@
             </a:outerShdw>
           </a:effectLst>
         </p:spPr>
+        <p:txBody>
+          <a:bodyPr/>
+          <a:p/>
+        </p:txBody>
       </p:sp>
       <p:sp>
         <p:nvSpPr>
@@ -17070,6 +17299,10 @@
             </a:outerShdw>
           </a:effectLst>
         </p:spPr>
+        <p:txBody>
+          <a:bodyPr/>
+          <a:p/>
+        </p:txBody>
       </p:sp>
       <p:sp>
         <p:nvSpPr>
@@ -17260,6 +17493,10 @@
             </a:outerShdw>
           </a:effectLst>
         </p:spPr>
+        <p:txBody>
+          <a:bodyPr/>
+          <a:p/>
+        </p:txBody>
       </p:sp>
       <p:sp>
         <p:nvSpPr>
@@ -17411,6 +17648,10 @@
             </a:outerShdw>
           </a:effectLst>
         </p:spPr>
+        <p:txBody>
+          <a:bodyPr/>
+          <a:p/>
+        </p:txBody>
       </p:sp>
       <p:sp>
         <p:nvSpPr>
@@ -17482,6 +17723,10 @@
             </a:outerShdw>
           </a:effectLst>
         </p:spPr>
+        <p:txBody>
+          <a:bodyPr/>
+          <a:p/>
+        </p:txBody>
       </p:sp>
       <p:pic>
         <p:nvPicPr>
@@ -17686,6 +17931,10 @@
             <a:prstDash val="solid"/>
           </a:ln>
         </p:spPr>
+        <p:txBody>
+          <a:bodyPr/>
+          <a:p/>
+        </p:txBody>
       </p:sp>
       <p:sp>
         <p:nvSpPr>
@@ -17720,6 +17969,10 @@
             </a:outerShdw>
           </a:effectLst>
         </p:spPr>
+        <p:txBody>
+          <a:bodyPr/>
+          <a:p/>
+        </p:txBody>
       </p:sp>
       <p:pic>
         <p:nvPicPr>
@@ -17885,6 +18138,10 @@
             <a:prstDash val="solid"/>
           </a:ln>
         </p:spPr>
+        <p:txBody>
+          <a:bodyPr/>
+          <a:p/>
+        </p:txBody>
       </p:sp>
       <p:sp>
         <p:nvSpPr>
@@ -17995,6 +18252,10 @@
             </a:outerShdw>
           </a:effectLst>
         </p:spPr>
+        <p:txBody>
+          <a:bodyPr/>
+          <a:p/>
+        </p:txBody>
       </p:sp>
       <p:sp>
         <p:nvSpPr>
@@ -18170,6 +18431,10 @@
             </a:outerShdw>
           </a:effectLst>
         </p:spPr>
+        <p:txBody>
+          <a:bodyPr/>
+          <a:p/>
+        </p:txBody>
       </p:sp>
       <p:sp>
         <p:nvSpPr>
@@ -18360,6 +18625,10 @@
             </a:outerShdw>
           </a:effectLst>
         </p:spPr>
+        <p:txBody>
+          <a:bodyPr/>
+          <a:p/>
+        </p:txBody>
       </p:sp>
       <p:sp>
         <p:nvSpPr>
@@ -18472,6 +18741,10 @@
             </a:outerShdw>
           </a:effectLst>
         </p:spPr>
+        <p:txBody>
+          <a:bodyPr/>
+          <a:p/>
+        </p:txBody>
       </p:sp>
       <p:sp>
         <p:nvSpPr>
@@ -18497,6 +18770,10 @@
             <a:prstDash val="solid"/>
           </a:ln>
         </p:spPr>
+        <p:txBody>
+          <a:bodyPr/>
+          <a:p/>
+        </p:txBody>
       </p:sp>
       <p:sp>
         <p:nvSpPr>
@@ -18648,6 +18925,10 @@
             </a:outerShdw>
           </a:effectLst>
         </p:spPr>
+        <p:txBody>
+          <a:bodyPr/>
+          <a:p/>
+        </p:txBody>
       </p:sp>
       <p:sp>
         <p:nvSpPr>
@@ -18673,6 +18954,10 @@
             <a:prstDash val="solid"/>
           </a:ln>
         </p:spPr>
+        <p:txBody>
+          <a:bodyPr/>
+          <a:p/>
+        </p:txBody>
       </p:sp>
       <p:sp>
         <p:nvSpPr>
@@ -18824,6 +19109,10 @@
             </a:outerShdw>
           </a:effectLst>
         </p:spPr>
+        <p:txBody>
+          <a:bodyPr/>
+          <a:p/>
+        </p:txBody>
       </p:sp>
       <p:sp>
         <p:nvSpPr>
@@ -18849,6 +19138,10 @@
             <a:prstDash val="solid"/>
           </a:ln>
         </p:spPr>
+        <p:txBody>
+          <a:bodyPr/>
+          <a:p/>
+        </p:txBody>
       </p:sp>
       <p:sp>
         <p:nvSpPr>
@@ -19000,6 +19293,10 @@
             </a:outerShdw>
           </a:effectLst>
         </p:spPr>
+        <p:txBody>
+          <a:bodyPr/>
+          <a:p/>
+        </p:txBody>
       </p:sp>
       <p:sp>
         <p:nvSpPr>
@@ -19025,6 +19322,10 @@
             <a:prstDash val="solid"/>
           </a:ln>
         </p:spPr>
+        <p:txBody>
+          <a:bodyPr/>
+          <a:p/>
+        </p:txBody>
       </p:sp>
       <p:sp>
         <p:nvSpPr>
@@ -19137,6 +19438,10 @@
             </a:outerShdw>
           </a:effectLst>
         </p:spPr>
+        <p:txBody>
+          <a:bodyPr/>
+          <a:p/>
+        </p:txBody>
       </p:sp>
       <p:sp>
         <p:nvSpPr>
@@ -19166,6 +19471,10 @@
             <a:prstDash val="solid"/>
           </a:ln>
         </p:spPr>
+        <p:txBody>
+          <a:bodyPr/>
+          <a:p/>
+        </p:txBody>
       </p:sp>
       <p:sp>
         <p:nvSpPr>
@@ -19368,6 +19677,10 @@
             </a:outerShdw>
           </a:effectLst>
         </p:spPr>
+        <p:txBody>
+          <a:bodyPr/>
+          <a:p/>
+        </p:txBody>
       </p:sp>
       <p:sp>
         <p:nvSpPr>
@@ -19543,6 +19856,10 @@
             </a:outerShdw>
           </a:effectLst>
         </p:spPr>
+        <p:txBody>
+          <a:bodyPr/>
+          <a:p/>
+        </p:txBody>
       </p:sp>
       <p:sp>
         <p:nvSpPr>
@@ -19648,6 +19965,10 @@
             <a:prstDash val="solid"/>
           </a:ln>
         </p:spPr>
+        <p:txBody>
+          <a:bodyPr/>
+          <a:p/>
+        </p:txBody>
       </p:sp>
       <p:sp>
         <p:nvSpPr>
@@ -19714,6 +20035,10 @@
             <a:prstDash val="solid"/>
           </a:ln>
         </p:spPr>
+        <p:txBody>
+          <a:bodyPr/>
+          <a:p/>
+        </p:txBody>
       </p:sp>
       <p:sp>
         <p:nvSpPr>
@@ -19780,6 +20105,10 @@
             <a:prstDash val="solid"/>
           </a:ln>
         </p:spPr>
+        <p:txBody>
+          <a:bodyPr/>
+          <a:p/>
+        </p:txBody>
       </p:sp>
       <p:sp>
         <p:nvSpPr>
@@ -19846,6 +20175,10 @@
             <a:prstDash val="solid"/>
           </a:ln>
         </p:spPr>
+        <p:txBody>
+          <a:bodyPr/>
+          <a:p/>
+        </p:txBody>
       </p:sp>
       <p:sp>
         <p:nvSpPr>
@@ -19912,6 +20245,10 @@
             <a:prstDash val="solid"/>
           </a:ln>
         </p:spPr>
+        <p:txBody>
+          <a:bodyPr/>
+          <a:p/>
+        </p:txBody>
       </p:sp>
       <p:sp>
         <p:nvSpPr>
@@ -19978,6 +20315,10 @@
             <a:prstDash val="solid"/>
           </a:ln>
         </p:spPr>
+        <p:txBody>
+          <a:bodyPr/>
+          <a:p/>
+        </p:txBody>
       </p:sp>
       <p:sp>
         <p:nvSpPr>
@@ -20044,6 +20385,10 @@
             <a:prstDash val="solid"/>
           </a:ln>
         </p:spPr>
+        <p:txBody>
+          <a:bodyPr/>
+          <a:p/>
+        </p:txBody>
       </p:sp>
       <p:sp>
         <p:nvSpPr>
@@ -20110,6 +20455,10 @@
             <a:prstDash val="solid"/>
           </a:ln>
         </p:spPr>
+        <p:txBody>
+          <a:bodyPr/>
+          <a:p/>
+        </p:txBody>
       </p:sp>
       <p:sp>
         <p:nvSpPr>
@@ -20176,6 +20525,10 @@
             <a:prstDash val="solid"/>
           </a:ln>
         </p:spPr>
+        <p:txBody>
+          <a:bodyPr/>
+          <a:p/>
+        </p:txBody>
       </p:sp>
       <p:sp>
         <p:nvSpPr>
@@ -20327,6 +20680,10 @@
             </a:outerShdw>
           </a:effectLst>
         </p:spPr>
+        <p:txBody>
+          <a:bodyPr/>
+          <a:p/>
+        </p:txBody>
       </p:sp>
       <p:sp>
         <p:nvSpPr>
@@ -20551,6 +20908,10 @@
             </a:outerShdw>
           </a:effectLst>
         </p:spPr>
+        <p:txBody>
+          <a:bodyPr/>
+          <a:p/>
+        </p:txBody>
       </p:sp>
       <p:sp>
         <p:nvSpPr>
@@ -20719,6 +21080,10 @@
             </a:outerShdw>
           </a:effectLst>
         </p:spPr>
+        <p:txBody>
+          <a:bodyPr/>
+          <a:p/>
+        </p:txBody>
       </p:sp>
       <p:sp>
         <p:nvSpPr>
@@ -20877,6 +21242,10 @@
             </a:outerShdw>
           </a:effectLst>
         </p:spPr>
+        <p:txBody>
+          <a:bodyPr/>
+          <a:p/>
+        </p:txBody>
       </p:sp>
       <p:sp>
         <p:nvSpPr>
@@ -21118,6 +21487,10 @@
             </a:outerShdw>
           </a:effectLst>
         </p:spPr>
+        <p:txBody>
+          <a:bodyPr/>
+          <a:p/>
+        </p:txBody>
       </p:sp>
       <p:sp>
         <p:nvSpPr>
@@ -21284,6 +21657,10 @@
             <a:prstDash val="solid"/>
           </a:ln>
         </p:spPr>
+        <p:txBody>
+          <a:bodyPr/>
+          <a:p/>
+        </p:txBody>
       </p:sp>
       <p:sp>
         <p:nvSpPr>
@@ -21316,6 +21693,10 @@
             </a:outerShdw>
           </a:effectLst>
         </p:spPr>
+        <p:txBody>
+          <a:bodyPr/>
+          <a:p/>
+        </p:txBody>
       </p:sp>
       <p:sp>
         <p:nvSpPr>
@@ -21521,6 +21902,10 @@
             </a:outerShdw>
           </a:effectLst>
         </p:spPr>
+        <p:txBody>
+          <a:bodyPr/>
+          <a:p/>
+        </p:txBody>
       </p:sp>
       <p:sp>
         <p:nvSpPr>
@@ -21726,6 +22111,10 @@
             </a:outerShdw>
           </a:effectLst>
         </p:spPr>
+        <p:txBody>
+          <a:bodyPr/>
+          <a:p/>
+        </p:txBody>
       </p:sp>
       <p:sp>
         <p:nvSpPr>
@@ -21931,6 +22320,10 @@
             </a:outerShdw>
           </a:effectLst>
         </p:spPr>
+        <p:txBody>
+          <a:bodyPr/>
+          <a:p/>
+        </p:txBody>
       </p:sp>
       <p:sp>
         <p:nvSpPr>
@@ -22121,6 +22514,10 @@
             </a:outerShdw>
           </a:effectLst>
         </p:spPr>
+        <p:txBody>
+          <a:bodyPr/>
+          <a:p/>
+        </p:txBody>
       </p:sp>
       <p:sp>
         <p:nvSpPr>
@@ -22468,6 +22865,10 @@
             </a:outerShdw>
           </a:effectLst>
         </p:spPr>
+        <p:txBody>
+          <a:bodyPr/>
+          <a:p/>
+        </p:txBody>
       </p:sp>
       <p:sp>
         <p:nvSpPr>
@@ -22643,6 +23044,10 @@
             </a:outerShdw>
           </a:effectLst>
         </p:spPr>
+        <p:txBody>
+          <a:bodyPr/>
+          <a:p/>
+        </p:txBody>
       </p:sp>
       <p:graphicFrame>
         <p:nvGraphicFramePr>
@@ -22693,6 +23098,10 @@
             </a:outerShdw>
           </a:effectLst>
         </p:spPr>
+        <p:txBody>
+          <a:bodyPr/>
+          <a:p/>
+        </p:txBody>
       </p:sp>
       <p:sp>
         <p:nvSpPr>
@@ -22878,6 +23287,10 @@
             <a:prstDash val="solid"/>
           </a:ln>
         </p:spPr>
+        <p:txBody>
+          <a:bodyPr/>
+          <a:p/>
+        </p:txBody>
       </p:sp>
       <p:sp>
         <p:nvSpPr>
@@ -23027,6 +23440,10 @@
             </a:outerShdw>
           </a:effectLst>
         </p:spPr>
+        <p:txBody>
+          <a:bodyPr/>
+          <a:p/>
+        </p:txBody>
       </p:sp>
       <p:sp>
         <p:nvSpPr>
@@ -23202,6 +23619,10 @@
             </a:outerShdw>
           </a:effectLst>
         </p:spPr>
+        <p:txBody>
+          <a:bodyPr/>
+          <a:p/>
+        </p:txBody>
       </p:sp>
       <p:pic>
         <p:nvPicPr>
@@ -23252,6 +23673,10 @@
             <a:prstDash val="solid"/>
           </a:ln>
         </p:spPr>
+        <p:txBody>
+          <a:bodyPr/>
+          <a:p/>
+        </p:txBody>
       </p:sp>
       <p:sp>
         <p:nvSpPr>
@@ -23318,6 +23743,10 @@
             <a:prstDash val="solid"/>
           </a:ln>
         </p:spPr>
+        <p:txBody>
+          <a:bodyPr/>
+          <a:p/>
+        </p:txBody>
       </p:sp>
       <p:sp>
         <p:nvSpPr>
@@ -23352,6 +23781,10 @@
             </a:outerShdw>
           </a:effectLst>
         </p:spPr>
+        <p:txBody>
+          <a:bodyPr/>
+          <a:p/>
+        </p:txBody>
       </p:sp>
       <p:pic>
         <p:nvPicPr>
@@ -23402,6 +23835,10 @@
             <a:prstDash val="solid"/>
           </a:ln>
         </p:spPr>
+        <p:txBody>
+          <a:bodyPr/>
+          <a:p/>
+        </p:txBody>
       </p:sp>
       <p:sp>
         <p:nvSpPr>
@@ -23590,6 +24027,10 @@
             </a:outerShdw>
           </a:effectLst>
         </p:spPr>
+        <p:txBody>
+          <a:bodyPr/>
+          <a:p/>
+        </p:txBody>
       </p:sp>
       <p:sp>
         <p:nvSpPr>
@@ -23765,6 +24206,10 @@
             </a:outerShdw>
           </a:effectLst>
         </p:spPr>
+        <p:txBody>
+          <a:bodyPr/>
+          <a:p/>
+        </p:txBody>
       </p:sp>
       <p:pic>
         <p:nvPicPr>
@@ -23815,6 +24260,10 @@
             <a:prstDash val="solid"/>
           </a:ln>
         </p:spPr>
+        <p:txBody>
+          <a:bodyPr/>
+          <a:p/>
+        </p:txBody>
       </p:sp>
       <p:sp>
         <p:nvSpPr>
@@ -23881,6 +24330,10 @@
             <a:prstDash val="solid"/>
           </a:ln>
         </p:spPr>
+        <p:txBody>
+          <a:bodyPr/>
+          <a:p/>
+        </p:txBody>
       </p:sp>
       <p:sp>
         <p:nvSpPr>
@@ -23915,6 +24368,10 @@
             </a:outerShdw>
           </a:effectLst>
         </p:spPr>
+        <p:txBody>
+          <a:bodyPr/>
+          <a:p/>
+        </p:txBody>
       </p:sp>
       <p:pic>
         <p:nvPicPr>
@@ -23965,6 +24422,10 @@
             <a:prstDash val="solid"/>
           </a:ln>
         </p:spPr>
+        <p:txBody>
+          <a:bodyPr/>
+          <a:p/>
+        </p:txBody>
       </p:sp>
       <p:sp>
         <p:nvSpPr>
@@ -24153,6 +24614,10 @@
             </a:outerShdw>
           </a:effectLst>
         </p:spPr>
+        <p:txBody>
+          <a:bodyPr/>
+          <a:p/>
+        </p:txBody>
       </p:sp>
       <p:sp>
         <p:nvSpPr>
@@ -24328,6 +24793,10 @@
             </a:outerShdw>
           </a:effectLst>
         </p:spPr>
+        <p:txBody>
+          <a:bodyPr/>
+          <a:p/>
+        </p:txBody>
       </p:sp>
       <p:pic>
         <p:nvPicPr>
@@ -24378,6 +24847,10 @@
             <a:prstDash val="solid"/>
           </a:ln>
         </p:spPr>
+        <p:txBody>
+          <a:bodyPr/>
+          <a:p/>
+        </p:txBody>
       </p:sp>
       <p:sp>
         <p:nvSpPr>
@@ -24444,6 +24917,10 @@
             <a:prstDash val="solid"/>
           </a:ln>
         </p:spPr>
+        <p:txBody>
+          <a:bodyPr/>
+          <a:p/>
+        </p:txBody>
       </p:sp>
       <p:sp>
         <p:nvSpPr>
@@ -24478,6 +24955,10 @@
             </a:outerShdw>
           </a:effectLst>
         </p:spPr>
+        <p:txBody>
+          <a:bodyPr/>
+          <a:p/>
+        </p:txBody>
       </p:sp>
       <p:pic>
         <p:nvPicPr>
@@ -24528,6 +25009,10 @@
             <a:prstDash val="solid"/>
           </a:ln>
         </p:spPr>
+        <p:txBody>
+          <a:bodyPr/>
+          <a:p/>
+        </p:txBody>
       </p:sp>
       <p:sp>
         <p:nvSpPr>
@@ -24716,6 +25201,10 @@
             </a:outerShdw>
           </a:effectLst>
         </p:spPr>
+        <p:txBody>
+          <a:bodyPr/>
+          <a:p/>
+        </p:txBody>
       </p:sp>
       <p:sp>
         <p:nvSpPr>
@@ -24928,6 +25417,10 @@
             </a:outerShdw>
           </a:effectLst>
         </p:spPr>
+        <p:txBody>
+          <a:bodyPr/>
+          <a:p/>
+        </p:txBody>
       </p:sp>
       <p:pic>
         <p:nvPicPr>
@@ -25061,6 +25554,10 @@
             </a:outerShdw>
           </a:effectLst>
         </p:spPr>
+        <p:txBody>
+          <a:bodyPr/>
+          <a:p/>
+        </p:txBody>
       </p:sp>
       <p:pic>
         <p:nvPicPr>
@@ -25152,6 +25649,10 @@
             <a:prstDash val="solid"/>
           </a:ln>
         </p:spPr>
+        <p:txBody>
+          <a:bodyPr/>
+          <a:p/>
+        </p:txBody>
       </p:sp>
       <p:sp>
         <p:nvSpPr>
@@ -25220,6 +25721,10 @@
             <a:prstDash val="solid"/>
           </a:ln>
         </p:spPr>
+        <p:txBody>
+          <a:bodyPr/>
+          <a:p/>
+        </p:txBody>
       </p:sp>
       <p:sp>
         <p:nvSpPr>
@@ -25369,6 +25874,10 @@
             </a:outerShdw>
           </a:effectLst>
         </p:spPr>
+        <p:txBody>
+          <a:bodyPr/>
+          <a:p/>
+        </p:txBody>
       </p:sp>
       <p:sp>
         <p:nvSpPr>
@@ -25544,6 +26053,10 @@
             </a:outerShdw>
           </a:effectLst>
         </p:spPr>
+        <p:txBody>
+          <a:bodyPr/>
+          <a:p/>
+        </p:txBody>
       </p:sp>
       <p:sp>
         <p:nvSpPr>
@@ -25688,6 +26201,10 @@
             <a:prstDash val="solid"/>
           </a:ln>
         </p:spPr>
+        <p:txBody>
+          <a:bodyPr/>
+          <a:p/>
+        </p:txBody>
       </p:sp>
       <p:sp>
         <p:nvSpPr>
@@ -25715,6 +26232,10 @@
             <a:prstDash val="solid"/>
           </a:ln>
         </p:spPr>
+        <p:txBody>
+          <a:bodyPr/>
+          <a:p/>
+        </p:txBody>
       </p:sp>
       <p:sp>
         <p:nvSpPr>
@@ -25820,6 +26341,10 @@
             <a:prstDash val="solid"/>
           </a:ln>
         </p:spPr>
+        <p:txBody>
+          <a:bodyPr/>
+          <a:p/>
+        </p:txBody>
       </p:sp>
       <p:sp>
         <p:nvSpPr>
@@ -25847,6 +26372,10 @@
             <a:prstDash val="solid"/>
           </a:ln>
         </p:spPr>
+        <p:txBody>
+          <a:bodyPr/>
+          <a:p/>
+        </p:txBody>
       </p:sp>
       <p:sp>
         <p:nvSpPr>
@@ -25915,6 +26444,10 @@
             <a:prstDash val="solid"/>
           </a:ln>
         </p:spPr>
+        <p:txBody>
+          <a:bodyPr/>
+          <a:p/>
+        </p:txBody>
       </p:sp>
       <p:sp>
         <p:nvSpPr>
@@ -25988,6 +26521,10 @@
             </a:outerShdw>
           </a:effectLst>
         </p:spPr>
+        <p:txBody>
+          <a:bodyPr/>
+          <a:p/>
+        </p:txBody>
       </p:sp>
       <p:sp>
         <p:nvSpPr>
@@ -26166,6 +26703,10 @@
             <a:prstDash val="solid"/>
           </a:ln>
         </p:spPr>
+        <p:txBody>
+          <a:bodyPr/>
+          <a:p/>
+        </p:txBody>
       </p:sp>
       <p:sp>
         <p:nvSpPr>
@@ -26234,6 +26775,10 @@
             <a:prstDash val="solid"/>
           </a:ln>
         </p:spPr>
+        <p:txBody>
+          <a:bodyPr/>
+          <a:p/>
+        </p:txBody>
       </p:sp>
       <p:sp>
         <p:nvSpPr>
@@ -26383,6 +26928,10 @@
             </a:outerShdw>
           </a:effectLst>
         </p:spPr>
+        <p:txBody>
+          <a:bodyPr/>
+          <a:p/>
+        </p:txBody>
       </p:sp>
       <p:sp>
         <p:nvSpPr>
@@ -26558,6 +27107,10 @@
             </a:outerShdw>
           </a:effectLst>
         </p:spPr>
+        <p:txBody>
+          <a:bodyPr/>
+          <a:p/>
+        </p:txBody>
       </p:sp>
       <p:sp>
         <p:nvSpPr>
@@ -26709,6 +27262,10 @@
             </a:outerShdw>
           </a:effectLst>
         </p:spPr>
+        <p:txBody>
+          <a:bodyPr/>
+          <a:p/>
+        </p:txBody>
       </p:sp>
       <p:sp>
         <p:nvSpPr>
@@ -26860,6 +27417,10 @@
             </a:outerShdw>
           </a:effectLst>
         </p:spPr>
+        <p:txBody>
+          <a:bodyPr/>
+          <a:p/>
+        </p:txBody>
       </p:sp>
       <p:sp>
         <p:nvSpPr>
@@ -27011,6 +27572,10 @@
             </a:outerShdw>
           </a:effectLst>
         </p:spPr>
+        <p:txBody>
+          <a:bodyPr/>
+          <a:p/>
+        </p:txBody>
       </p:sp>
       <p:sp>
         <p:nvSpPr>
@@ -27115,15 +27680,11 @@
               <a:buNone/>
             </a:pPr>
             <a:r>
-              <a:rPr lang="en-US" sz="1200" dirty="0">
-                <a:solidFill>
-                  <a:srgbClr val="5FD0B0"/>
-                </a:solidFill>
-                <a:latin typeface="Malgun Gothic" pitchFamily="34" charset="0"/>
-                <a:ea typeface="Malgun Gothic" pitchFamily="34" charset="-122"/>
-                <a:cs typeface="Malgun Gothic" pitchFamily="34" charset="-120"/>
-              </a:rPr>
               <a:t>연초 대비 +25개</a:t>
+            </a:r>
+            <a:br/>
+            <a:r>
+              <a:t>수도권 190 · 영남권 155 · 충청권 97 · 호남권 73 · 강원권 23 · 제주권 7</a:t>
             </a:r>
             <a:endParaRPr lang="en-US" sz="1200" dirty="0"/>
           </a:p>
@@ -27162,6 +27723,10 @@
             </a:outerShdw>
           </a:effectLst>
         </p:spPr>
+        <p:txBody>
+          <a:bodyPr/>
+          <a:p/>
+        </p:txBody>
       </p:sp>
       <p:graphicFrame>
         <p:nvGraphicFramePr>
@@ -27212,6 +27777,10 @@
             </a:outerShdw>
           </a:effectLst>
         </p:spPr>
+        <p:txBody>
+          <a:bodyPr/>
+          <a:p/>
+        </p:txBody>
       </p:sp>
       <p:sp>
         <p:nvSpPr>
@@ -27517,6 +28086,10 @@
             <a:prstDash val="solid"/>
           </a:ln>
         </p:spPr>
+        <p:txBody>
+          <a:bodyPr/>
+          <a:p/>
+        </p:txBody>
       </p:sp>
       <p:sp>
         <p:nvSpPr>
@@ -27551,6 +28124,10 @@
             </a:outerShdw>
           </a:effectLst>
         </p:spPr>
+        <p:txBody>
+          <a:bodyPr/>
+          <a:p/>
+        </p:txBody>
       </p:sp>
       <p:pic>
         <p:nvPicPr>
@@ -27716,6 +28293,10 @@
             <a:prstDash val="solid"/>
           </a:ln>
         </p:spPr>
+        <p:txBody>
+          <a:bodyPr/>
+          <a:p/>
+        </p:txBody>
       </p:sp>
       <p:sp>
         <p:nvSpPr>
@@ -27826,6 +28407,10 @@
             </a:outerShdw>
           </a:effectLst>
         </p:spPr>
+        <p:txBody>
+          <a:bodyPr/>
+          <a:p/>
+        </p:txBody>
       </p:sp>
       <p:sp>
         <p:nvSpPr>
@@ -28001,6 +28586,10 @@
             </a:outerShdw>
           </a:effectLst>
         </p:spPr>
+        <p:txBody>
+          <a:bodyPr/>
+          <a:p/>
+        </p:txBody>
       </p:sp>
       <p:sp>
         <p:nvSpPr>
@@ -28191,6 +28780,10 @@
             </a:outerShdw>
           </a:effectLst>
         </p:spPr>
+        <p:txBody>
+          <a:bodyPr/>
+          <a:p/>
+        </p:txBody>
       </p:sp>
       <p:sp>
         <p:nvSpPr>
@@ -28395,6 +28988,10 @@
             </a:outerShdw>
           </a:effectLst>
         </p:spPr>
+        <p:txBody>
+          <a:bodyPr/>
+          <a:p/>
+        </p:txBody>
       </p:sp>
       <p:sp>
         <p:nvSpPr>
@@ -28597,6 +29194,10 @@
             <a:prstDash val="solid"/>
           </a:ln>
         </p:spPr>
+        <p:txBody>
+          <a:bodyPr/>
+          <a:p/>
+        </p:txBody>
       </p:sp>
       <p:sp>
         <p:nvSpPr>
@@ -28665,6 +29266,10 @@
             <a:prstDash val="solid"/>
           </a:ln>
         </p:spPr>
+        <p:txBody>
+          <a:bodyPr/>
+          <a:p/>
+        </p:txBody>
       </p:sp>
       <p:sp>
         <p:nvSpPr>
@@ -28733,6 +29338,10 @@
             <a:prstDash val="solid"/>
           </a:ln>
         </p:spPr>
+        <p:txBody>
+          <a:bodyPr/>
+          <a:p/>
+        </p:txBody>
       </p:sp>
       <p:sp>
         <p:nvSpPr>
@@ -28801,6 +29410,10 @@
             <a:prstDash val="solid"/>
           </a:ln>
         </p:spPr>
+        <p:txBody>
+          <a:bodyPr/>
+          <a:p/>
+        </p:txBody>
       </p:sp>
       <p:sp>
         <p:nvSpPr>
@@ -28869,6 +29482,10 @@
             <a:prstDash val="solid"/>
           </a:ln>
         </p:spPr>
+        <p:txBody>
+          <a:bodyPr/>
+          <a:p/>
+        </p:txBody>
       </p:sp>
       <p:sp>
         <p:nvSpPr>
@@ -28942,6 +29559,10 @@
             </a:outerShdw>
           </a:effectLst>
         </p:spPr>
+        <p:txBody>
+          <a:bodyPr/>
+          <a:p/>
+        </p:txBody>
       </p:sp>
       <p:sp>
         <p:nvSpPr>
@@ -29315,6 +29936,10 @@
             </a:outerShdw>
           </a:effectLst>
         </p:spPr>
+        <p:txBody>
+          <a:bodyPr/>
+          <a:p/>
+        </p:txBody>
       </p:sp>
       <p:sp>
         <p:nvSpPr>
@@ -29490,6 +30115,10 @@
             </a:outerShdw>
           </a:effectLst>
         </p:spPr>
+        <p:txBody>
+          <a:bodyPr/>
+          <a:p/>
+        </p:txBody>
       </p:sp>
       <p:sp>
         <p:nvSpPr>
@@ -29515,6 +30144,10 @@
             <a:prstDash val="solid"/>
           </a:ln>
         </p:spPr>
+        <p:txBody>
+          <a:bodyPr/>
+          <a:p/>
+        </p:txBody>
       </p:sp>
       <p:sp>
         <p:nvSpPr>
@@ -29705,6 +30338,10 @@
             </a:outerShdw>
           </a:effectLst>
         </p:spPr>
+        <p:txBody>
+          <a:bodyPr/>
+          <a:p/>
+        </p:txBody>
       </p:sp>
       <p:sp>
         <p:nvSpPr>
@@ -29730,6 +30367,10 @@
             <a:prstDash val="solid"/>
           </a:ln>
         </p:spPr>
+        <p:txBody>
+          <a:bodyPr/>
+          <a:p/>
+        </p:txBody>
       </p:sp>
       <p:sp>
         <p:nvSpPr>
@@ -29920,6 +30561,10 @@
             </a:outerShdw>
           </a:effectLst>
         </p:spPr>
+        <p:txBody>
+          <a:bodyPr/>
+          <a:p/>
+        </p:txBody>
       </p:sp>
       <p:sp>
         <p:nvSpPr>
@@ -29945,6 +30590,10 @@
             <a:prstDash val="solid"/>
           </a:ln>
         </p:spPr>
+        <p:txBody>
+          <a:bodyPr/>
+          <a:p/>
+        </p:txBody>
       </p:sp>
       <p:sp>
         <p:nvSpPr>
@@ -30135,6 +30784,10 @@
             </a:outerShdw>
           </a:effectLst>
         </p:spPr>
+        <p:txBody>
+          <a:bodyPr/>
+          <a:p/>
+        </p:txBody>
       </p:sp>
       <p:sp>
         <p:nvSpPr>
@@ -30160,6 +30813,10 @@
             <a:prstDash val="solid"/>
           </a:ln>
         </p:spPr>
+        <p:txBody>
+          <a:bodyPr/>
+          <a:p/>
+        </p:txBody>
       </p:sp>
       <p:sp>
         <p:nvSpPr>
@@ -30367,6 +31024,10 @@
             </a:outerShdw>
           </a:effectLst>
         </p:spPr>
+        <p:txBody>
+          <a:bodyPr/>
+          <a:p/>
+        </p:txBody>
       </p:sp>
       <p:sp>
         <p:nvSpPr>
@@ -30392,6 +31053,10 @@
             <a:prstDash val="solid"/>
           </a:ln>
         </p:spPr>
+        <p:txBody>
+          <a:bodyPr/>
+          <a:p/>
+        </p:txBody>
       </p:sp>
       <p:sp>
         <p:nvSpPr>
@@ -30599,6 +31264,10 @@
             </a:outerShdw>
           </a:effectLst>
         </p:spPr>
+        <p:txBody>
+          <a:bodyPr/>
+          <a:p/>
+        </p:txBody>
       </p:sp>
       <p:sp>
         <p:nvSpPr>
@@ -30624,6 +31293,10 @@
             <a:prstDash val="solid"/>
           </a:ln>
         </p:spPr>
+        <p:txBody>
+          <a:bodyPr/>
+          <a:p/>
+        </p:txBody>
       </p:sp>
       <p:sp>
         <p:nvSpPr>
@@ -30890,6 +31563,10 @@
             </a:outerShdw>
           </a:effectLst>
         </p:spPr>
+        <p:txBody>
+          <a:bodyPr/>
+          <a:p/>
+        </p:txBody>
       </p:sp>
       <p:sp>
         <p:nvSpPr>
@@ -31056,6 +31733,10 @@
             <a:prstDash val="solid"/>
           </a:ln>
         </p:spPr>
+        <p:txBody>
+          <a:bodyPr/>
+          <a:p/>
+        </p:txBody>
       </p:sp>
       <p:sp>
         <p:nvSpPr>
@@ -31088,6 +31769,10 @@
             </a:outerShdw>
           </a:effectLst>
         </p:spPr>
+        <p:txBody>
+          <a:bodyPr/>
+          <a:p/>
+        </p:txBody>
       </p:sp>
       <p:sp>
         <p:nvSpPr>
@@ -31237,6 +31922,10 @@
             </a:outerShdw>
           </a:effectLst>
         </p:spPr>
+        <p:txBody>
+          <a:bodyPr/>
+          <a:p/>
+        </p:txBody>
       </p:sp>
       <p:sp>
         <p:nvSpPr>
@@ -31386,6 +32075,10 @@
             </a:outerShdw>
           </a:effectLst>
         </p:spPr>
+        <p:txBody>
+          <a:bodyPr/>
+          <a:p/>
+        </p:txBody>
       </p:sp>
       <p:sp>
         <p:nvSpPr>
@@ -31535,6 +32228,10 @@
             </a:outerShdw>
           </a:effectLst>
         </p:spPr>
+        <p:txBody>
+          <a:bodyPr/>
+          <a:p/>
+        </p:txBody>
       </p:sp>
       <p:sp>
         <p:nvSpPr>
@@ -31686,6 +32383,10 @@
             </a:outerShdw>
           </a:effectLst>
         </p:spPr>
+        <p:txBody>
+          <a:bodyPr/>
+          <a:p/>
+        </p:txBody>
       </p:sp>
       <p:sp>
         <p:nvSpPr>
@@ -31754,6 +32455,10 @@
             <a:prstDash val="solid"/>
           </a:ln>
         </p:spPr>
+        <p:txBody>
+          <a:bodyPr/>
+          <a:p/>
+        </p:txBody>
       </p:sp>
       <p:sp>
         <p:nvSpPr>
@@ -31822,6 +32527,10 @@
             <a:prstDash val="solid"/>
           </a:ln>
         </p:spPr>
+        <p:txBody>
+          <a:bodyPr/>
+          <a:p/>
+        </p:txBody>
       </p:sp>
       <p:sp>
         <p:nvSpPr>
@@ -31890,6 +32599,10 @@
             <a:prstDash val="solid"/>
           </a:ln>
         </p:spPr>
+        <p:txBody>
+          <a:bodyPr/>
+          <a:p/>
+        </p:txBody>
       </p:sp>
       <p:sp>
         <p:nvSpPr>
@@ -31958,6 +32671,10 @@
             <a:prstDash val="solid"/>
           </a:ln>
         </p:spPr>
+        <p:txBody>
+          <a:bodyPr/>
+          <a:p/>
+        </p:txBody>
       </p:sp>
       <p:sp>
         <p:nvSpPr>
@@ -32026,6 +32743,10 @@
             <a:prstDash val="solid"/>
           </a:ln>
         </p:spPr>
+        <p:txBody>
+          <a:bodyPr/>
+          <a:p/>
+        </p:txBody>
       </p:sp>
       <p:sp>
         <p:nvSpPr>
@@ -32094,6 +32815,10 @@
             <a:prstDash val="solid"/>
           </a:ln>
         </p:spPr>
+        <p:txBody>
+          <a:bodyPr/>
+          <a:p/>
+        </p:txBody>
       </p:sp>
       <p:sp>
         <p:nvSpPr>
@@ -32162,6 +32887,10 @@
             <a:prstDash val="solid"/>
           </a:ln>
         </p:spPr>
+        <p:txBody>
+          <a:bodyPr/>
+          <a:p/>
+        </p:txBody>
       </p:sp>
       <p:sp>
         <p:nvSpPr>
@@ -32188,15 +32917,7 @@
               <a:buNone/>
             </a:pPr>
             <a:r>
-              <a:rPr lang="en-US" sz="1200" b="1" dirty="0">
-                <a:solidFill>
-                  <a:srgbClr val="F3DCA4"/>
-                </a:solidFill>
-                <a:latin typeface="Malgun Gothic" pitchFamily="34" charset="0"/>
-                <a:ea typeface="Malgun Gothic" pitchFamily="34" charset="-122"/>
-                <a:cs typeface="Malgun Gothic" pitchFamily="34" charset="-120"/>
-              </a:rPr>
-              <a:t>모바일결제</a:t>
+              <a:t>모바일결재</a:t>
             </a:r>
             <a:endParaRPr lang="en-US" sz="1200" dirty="0"/>
           </a:p>
@@ -32274,6 +32995,10 @@
             </a:outerShdw>
           </a:effectLst>
         </p:spPr>
+        <p:txBody>
+          <a:bodyPr/>
+          <a:p/>
+        </p:txBody>
       </p:sp>
       <p:sp>
         <p:nvSpPr>
@@ -32431,6 +33156,10 @@
             </a:outerShdw>
           </a:effectLst>
         </p:spPr>
+        <p:txBody>
+          <a:bodyPr/>
+          <a:p/>
+        </p:txBody>
       </p:sp>
       <p:sp>
         <p:nvSpPr>
@@ -32560,6 +33289,10 @@
             </a:outerShdw>
           </a:effectLst>
         </p:spPr>
+        <p:txBody>
+          <a:bodyPr/>
+          <a:p/>
+        </p:txBody>
       </p:sp>
       <p:sp>
         <p:nvSpPr>
@@ -32748,6 +33481,10 @@
             </a:outerShdw>
           </a:effectLst>
         </p:spPr>
+        <p:txBody>
+          <a:bodyPr/>
+          <a:p/>
+        </p:txBody>
       </p:sp>
       <p:sp>
         <p:nvSpPr>
@@ -32923,6 +33660,10 @@
             </a:outerShdw>
           </a:effectLst>
         </p:spPr>
+        <p:txBody>
+          <a:bodyPr/>
+          <a:p/>
+        </p:txBody>
       </p:sp>
       <p:sp>
         <p:nvSpPr>
@@ -33052,6 +33793,10 @@
             </a:outerShdw>
           </a:effectLst>
         </p:spPr>
+        <p:txBody>
+          <a:bodyPr/>
+          <a:p/>
+        </p:txBody>
       </p:sp>
       <p:sp>
         <p:nvSpPr>
@@ -33181,6 +33926,10 @@
             </a:outerShdw>
           </a:effectLst>
         </p:spPr>
+        <p:txBody>
+          <a:bodyPr/>
+          <a:p/>
+        </p:txBody>
       </p:sp>
       <p:sp>
         <p:nvSpPr>
@@ -33618,6 +34367,10 @@
             <a:prstDash val="solid"/>
           </a:ln>
         </p:spPr>
+        <p:txBody>
+          <a:bodyPr/>
+          <a:p/>
+        </p:txBody>
       </p:sp>
       <p:sp>
         <p:nvSpPr>
@@ -33652,6 +34405,10 @@
             </a:outerShdw>
           </a:effectLst>
         </p:spPr>
+        <p:txBody>
+          <a:bodyPr/>
+          <a:p/>
+        </p:txBody>
       </p:sp>
       <p:pic>
         <p:nvPicPr>
@@ -33817,6 +34574,10 @@
             <a:prstDash val="solid"/>
           </a:ln>
         </p:spPr>
+        <p:txBody>
+          <a:bodyPr/>
+          <a:p/>
+        </p:txBody>
       </p:sp>
       <p:sp>
         <p:nvSpPr>
@@ -33959,6 +34720,10 @@
             <a:prstDash val="solid"/>
           </a:ln>
         </p:spPr>
+        <p:txBody>
+          <a:bodyPr/>
+          <a:p/>
+        </p:txBody>
       </p:sp>
       <p:sp>
         <p:nvSpPr>
@@ -33993,6 +34758,10 @@
             </a:outerShdw>
           </a:effectLst>
         </p:spPr>
+        <p:txBody>
+          <a:bodyPr/>
+          <a:p/>
+        </p:txBody>
       </p:sp>
       <p:pic>
         <p:nvPicPr>
@@ -34158,6 +34927,10 @@
             <a:prstDash val="solid"/>
           </a:ln>
         </p:spPr>
+        <p:txBody>
+          <a:bodyPr/>
+          <a:p/>
+        </p:txBody>
       </p:sp>
       <p:sp>
         <p:nvSpPr>
@@ -34300,6 +35073,10 @@
             <a:prstDash val="solid"/>
           </a:ln>
         </p:spPr>
+        <p:txBody>
+          <a:bodyPr/>
+          <a:p/>
+        </p:txBody>
       </p:sp>
       <p:sp>
         <p:nvSpPr>
@@ -34334,6 +35111,10 @@
             </a:outerShdw>
           </a:effectLst>
         </p:spPr>
+        <p:txBody>
+          <a:bodyPr/>
+          <a:p/>
+        </p:txBody>
       </p:sp>
       <p:pic>
         <p:nvPicPr>
@@ -34499,6 +35280,10 @@
             <a:prstDash val="solid"/>
           </a:ln>
         </p:spPr>
+        <p:txBody>
+          <a:bodyPr/>
+          <a:p/>
+        </p:txBody>
       </p:sp>
       <p:sp>
         <p:nvSpPr>
@@ -34641,6 +35426,10 @@
             <a:prstDash val="solid"/>
           </a:ln>
         </p:spPr>
+        <p:txBody>
+          <a:bodyPr/>
+          <a:p/>
+        </p:txBody>
       </p:sp>
       <p:sp>
         <p:nvSpPr>
@@ -34675,6 +35464,10 @@
             </a:outerShdw>
           </a:effectLst>
         </p:spPr>
+        <p:txBody>
+          <a:bodyPr/>
+          <a:p/>
+        </p:txBody>
       </p:sp>
       <p:pic>
         <p:nvPicPr>
@@ -34840,6 +35633,10 @@
             <a:prstDash val="solid"/>
           </a:ln>
         </p:spPr>
+        <p:txBody>
+          <a:bodyPr/>
+          <a:p/>
+        </p:txBody>
       </p:sp>
       <p:sp>
         <p:nvSpPr>
@@ -34982,6 +35779,10 @@
             <a:prstDash val="solid"/>
           </a:ln>
         </p:spPr>
+        <p:txBody>
+          <a:bodyPr/>
+          <a:p/>
+        </p:txBody>
       </p:sp>
       <p:sp>
         <p:nvSpPr>
@@ -35016,6 +35817,10 @@
             </a:outerShdw>
           </a:effectLst>
         </p:spPr>
+        <p:txBody>
+          <a:bodyPr/>
+          <a:p/>
+        </p:txBody>
       </p:sp>
       <p:pic>
         <p:nvPicPr>
@@ -35181,6 +35986,10 @@
             <a:prstDash val="solid"/>
           </a:ln>
         </p:spPr>
+        <p:txBody>
+          <a:bodyPr/>
+          <a:p/>
+        </p:txBody>
       </p:sp>
       <p:sp>
         <p:nvSpPr>
@@ -35323,6 +36132,10 @@
             <a:prstDash val="solid"/>
           </a:ln>
         </p:spPr>
+        <p:txBody>
+          <a:bodyPr/>
+          <a:p/>
+        </p:txBody>
       </p:sp>
       <p:sp>
         <p:nvSpPr>
@@ -35357,6 +36170,10 @@
             </a:outerShdw>
           </a:effectLst>
         </p:spPr>
+        <p:txBody>
+          <a:bodyPr/>
+          <a:p/>
+        </p:txBody>
       </p:sp>
       <p:pic>
         <p:nvPicPr>
@@ -35522,6 +36339,10 @@
             <a:prstDash val="solid"/>
           </a:ln>
         </p:spPr>
+        <p:txBody>
+          <a:bodyPr/>
+          <a:p/>
+        </p:txBody>
       </p:sp>
       <p:sp>
         <p:nvSpPr>

</xml_diff>